<commit_message>
Ajuste ppt aulas e code Jaca
</commit_message>
<xml_diff>
--- a/01 Classes/Aula 01 Desenvolvimento de Software Java Caracterização.pptx
+++ b/01 Classes/Aula 01 Desenvolvimento de Software Java Caracterização.pptx
@@ -4987,8 +4987,21 @@
                   <a:schemeClr val="bg1"/>
                 </a:solidFill>
               </a:rPr>
-              <a:t>Desenvolvimento de Software HTML, CSS, JS e JAVA</a:t>
-            </a:r>
+              <a:t>Desenvolvimento de Software HTML, CSS, JS </a:t>
+            </a:r>
+            <a:r>
+              <a:rPr lang="pt-BR" sz="4800" b="1">
+                <a:solidFill>
+                  <a:schemeClr val="bg1"/>
+                </a:solidFill>
+              </a:rPr>
+              <a:t>e JAVA </a:t>
+            </a:r>
+            <a:endParaRPr lang="pt-BR" sz="4800" b="1" dirty="0">
+              <a:solidFill>
+                <a:schemeClr val="bg1"/>
+              </a:solidFill>
+            </a:endParaRPr>
           </a:p>
         </p:txBody>
       </p:sp>

</xml_diff>